<commit_message>
Explain Eiffel placement and follow the live proposal branch
</commit_message>
<xml_diff>
--- a/extras/usd/examples/usdGeospatial/delivery/output/Geospatial-USD-proposal-assessment.pptx
+++ b/extras/usd/examples/usdGeospatial/delivery/output/Geospatial-USD-proposal-assessment.pptx
@@ -2,24 +2,24 @@
 <file path=ppt/presentation.xml><?xml version="1.0" encoding="utf-8"?>
 <p:presentation xmlns:p="http://schemas.openxmlformats.org/presentationml/2006/main">
   <p:sldMasterIdLst>
-    <p:sldMasterId xmlns:r="http://schemas.openxmlformats.org/officeDocument/2006/relationships" id="2147483648" r:id="R0fc8efd49f2744bd"/>
+    <p:sldMasterId xmlns:r="http://schemas.openxmlformats.org/officeDocument/2006/relationships" id="2147483648" r:id="R94bd95358b424c21"/>
   </p:sldMasterIdLst>
   <p:notesMasterIdLst>
-    <p:notesMasterId xmlns:r="http://schemas.openxmlformats.org/officeDocument/2006/relationships" r:id="R91c39d3ea8864517"/>
+    <p:notesMasterId xmlns:r="http://schemas.openxmlformats.org/officeDocument/2006/relationships" r:id="Rbd90fed0f5e045c0"/>
   </p:notesMasterIdLst>
   <p:sldIdLst>
-    <p:sldId xmlns:r="http://schemas.openxmlformats.org/officeDocument/2006/relationships" id="256" r:id="R37c29c3a6ae04fb7"/>
-    <p:sldId xmlns:r="http://schemas.openxmlformats.org/officeDocument/2006/relationships" id="257" r:id="R3d6f3f6c358a4d41"/>
-    <p:sldId xmlns:r="http://schemas.openxmlformats.org/officeDocument/2006/relationships" id="258" r:id="R46768e1592074c95"/>
-    <p:sldId xmlns:r="http://schemas.openxmlformats.org/officeDocument/2006/relationships" id="259" r:id="R878860219c8d4246"/>
-    <p:sldId xmlns:r="http://schemas.openxmlformats.org/officeDocument/2006/relationships" id="260" r:id="R9a0b921074f44f3a"/>
-    <p:sldId xmlns:r="http://schemas.openxmlformats.org/officeDocument/2006/relationships" id="261" r:id="Rcade1abab9b14ebc"/>
-    <p:sldId xmlns:r="http://schemas.openxmlformats.org/officeDocument/2006/relationships" id="262" r:id="Rd45840e7a53f47f7"/>
-    <p:sldId xmlns:r="http://schemas.openxmlformats.org/officeDocument/2006/relationships" id="263" r:id="R508743b3be554e83"/>
-    <p:sldId xmlns:r="http://schemas.openxmlformats.org/officeDocument/2006/relationships" id="264" r:id="Rb98f9556292145bc"/>
-    <p:sldId xmlns:r="http://schemas.openxmlformats.org/officeDocument/2006/relationships" id="265" r:id="Rc23883a8684b43c2"/>
-    <p:sldId xmlns:r="http://schemas.openxmlformats.org/officeDocument/2006/relationships" id="266" r:id="R911f3c5a7dcf4c55"/>
-    <p:sldId xmlns:r="http://schemas.openxmlformats.org/officeDocument/2006/relationships" id="267" r:id="R7f298bb1055f426e"/>
+    <p:sldId xmlns:r="http://schemas.openxmlformats.org/officeDocument/2006/relationships" id="256" r:id="R3c9160a636b642e3"/>
+    <p:sldId xmlns:r="http://schemas.openxmlformats.org/officeDocument/2006/relationships" id="257" r:id="R9d3856cf2e814281"/>
+    <p:sldId xmlns:r="http://schemas.openxmlformats.org/officeDocument/2006/relationships" id="258" r:id="R9de7a5af35904ab4"/>
+    <p:sldId xmlns:r="http://schemas.openxmlformats.org/officeDocument/2006/relationships" id="259" r:id="R12179dc1ea344daf"/>
+    <p:sldId xmlns:r="http://schemas.openxmlformats.org/officeDocument/2006/relationships" id="260" r:id="Rd16777a66d884a71"/>
+    <p:sldId xmlns:r="http://schemas.openxmlformats.org/officeDocument/2006/relationships" id="261" r:id="Re6b4ebfe2c684240"/>
+    <p:sldId xmlns:r="http://schemas.openxmlformats.org/officeDocument/2006/relationships" id="262" r:id="Rd99b8d2c4ea34c67"/>
+    <p:sldId xmlns:r="http://schemas.openxmlformats.org/officeDocument/2006/relationships" id="263" r:id="R4f3dd0f0f7e247ae"/>
+    <p:sldId xmlns:r="http://schemas.openxmlformats.org/officeDocument/2006/relationships" id="264" r:id="R620ed819b7e249d2"/>
+    <p:sldId xmlns:r="http://schemas.openxmlformats.org/officeDocument/2006/relationships" id="265" r:id="Rcb6857ff6f7b4984"/>
+    <p:sldId xmlns:r="http://schemas.openxmlformats.org/officeDocument/2006/relationships" id="266" r:id="Rd375136261634efb"/>
+    <p:sldId xmlns:r="http://schemas.openxmlformats.org/officeDocument/2006/relationships" id="267" r:id="R8a7f81f833ba412f"/>
   </p:sldIdLst>
   <p:sldSz cx="12192000" cy="6858000"/>
   <p:notesSz cx="6858000" cy="9144000"/>
@@ -703,7 +703,7 @@
           </a:p>
           <a:p xmlns:a="http://schemas.openxmlformats.org/drawingml/2006/main">
             <a:r>
-              <a:t>The fresh run found implementation defects and repaired them against existing requirements. It found no new blocking model or runtime ambiguity in the exercised contracts. Remaining review/adoption questions, explicit roadmap deferrals and prototype coverage limits are different claims and must remain visible when assessing readiness. | Category | Current assessment | |---|---| | Missing meaning in tested contracts | No new blocking gap found; bounded evidence | | Review and adoption | Detailed candidate conventions and Profiles identity ownership still require standards review | | Explicit deferrals | Coordinate epochs and scene-authored operation/resource pinning | | Prototype limits | General continuous-domain certification, custom GeoTIFF decoding and point-instancer bake expansion are visibly unsupported | | Independence of evidence | Same author and PROJ family; provider tables also use PROJ | Evidence. Reverse audit. The audit caught implicit epoch handling, a float-frame precision defect, incorrect CF assumptions and an unnecessary working-CRS conversion. Their repairs required no extra USD source attributes. Semantic normal primvar transport is exercised; full combinations of indexed, animated and non-mesh export are not certified. Review claims are intentionally narrower than “all possible implementations will agree.” ### Reproduce and inspect See REPRODUCE.md. The Python reader, native reader, new fixture generator, native-format adapters, ordinary exporter and acceptance cases were generated for this run. No source proposal edits, remote pushes, comments or messages are part of this delivery. The two readers use PROJ 9.5.1 and 9.4.1 respectively. The installed native USD SDK is 26.11; Python's USD is 26.5. The native Profiles API supplies declaration authoring/readback where the older Python bindings lack it. These version differences are recorded implementation context, not geospatial source fields. Original input hashes, code/resource provenance and the final assessment are in audit. Source and derived inputs have different provenance. Provider files and the original artist asset retain their supplied licenses and credits; this run does not infer redistribution rights or dependency approval.</a:t>
+              <a:t>The fresh run found implementation defects and repaired them against existing requirements. It found no new blocking model or runtime ambiguity in the exercised contracts. Remaining review/adoption questions, explicit roadmap deferrals and prototype coverage limits are different claims and must remain visible when assessing readiness. | Category | Current assessment | |---|---| | Missing meaning in tested contracts | No new blocking gap found; bounded evidence | | Review and adoption | Detailed candidate conventions and Profiles identity ownership still require standards review | | Explicit deferrals | Coordinate epochs and scene-authored operation/resource pinning | | Prototype limits | General continuous-domain certification, custom GeoTIFF decoding and point-instancer bake expansion are visibly unsupported | | Independence of evidence | Same author and PROJ family; provider tables also use PROJ | Evidence. Reverse audit. The audit caught implicit epoch handling, a float-frame precision defect, incorrect CF assumptions and an unnecessary working-CRS conversion. Their repairs required no extra USD source attributes. Semantic normal primvar transport is exercised; full combinations of indexed, animated and non-mesh export are not certified. Review claims are intentionally narrower than “all possible implementations will agree.” ### Reproduce and inspect See REPRODUCE.md. The Python reader, native reader, new fixture generator, native-format adapters, ordinary exporter and acceptance cases were generated for this run. The build made no source proposal edits. Its source and recorded evidence are published here as a draft companion; the original freeze records describe the run before publication. The two readers use PROJ 9.5.1 and 9.4.1 respectively. The installed native USD SDK is 26.11; Python's USD is 26.5. The native Profiles API supplies declaration authoring/readback where the older Python bindings lack it. These version differences are recorded implementation context, not geospatial source fields. Original input hashes, code/resource provenance and the final assessment are in audit. Source and derived inputs have different provenance. Provider files and the original artist asset retain their supplied licenses and credits; this run does not infer redistribution rights or dependency approval.</a:t>
             </a:r>
           </a:p>
         </p:txBody>
@@ -1023,7 +1023,7 @@
           </a:p>
           <a:p xmlns:a="http://schemas.openxmlformats.org/drawingml/2006/main">
             <a:r>
-              <a:t>The two readers resolve all 163,416 original Eiffel vertices, with a maximum difference of 0.016 mm between their ordinary bakes. A fresh reader reconstructs the Python bake within 0.011 mm. Native Hydra/Storm renders the derived geometry, and a real Omniverse stage reads the Python result back without a geospatial resolver. !Actual Hydra/Storm render of the fresh native-reader geometry on a 50-metre presentation grid Caption: Both readers use PROJ. Placement and resize are illustrative; the ground is not surveyed Paris context. Evidence. Full-data comparison, fresh-bake precision, actual Omniverse readback. There are two placement readers, Python and native C++. Omniverse is a consumer of Python results, not a third implementation or an integration with an additional geospatial runtime. Both readers share PROJ; the native reader reads the composed USD inputs itself. Neutral export formatting is shared. The original artist asset receives explicit cm/Y-up conformance and an illustrative resize to 300 m before the shown project scale. The ground and camera chart explain placement; they are not surveyed Paris context.</a:t>
+              <a:t>The two readers resolve all 163,416 original Eiffel vertices, with a maximum difference of 0.016 mm between their ordinary bakes. A fresh reader reconstructs the Python bake within 0.011 mm. Native Hydra/Storm renders the derived geometry, and a real Omniverse stage reads the Python result back without a geospatial resolver. !Authored tower location, before/after ordinary USD adjustment, and measured Python/C++ agreement Caption: Authored placement, then USD adjustment. Tower: SDC PERFORMANCE, CC BY 4.0 (modified). Both readers use PROJ. Evidence. Placement figure inputs and measured shift, full-data comparison, fresh-bake precision, actual Hydra/Storm render, actual Omniverse readback. There are two placement readers, Python and native C++. Omniverse is a consumer of Python results, not a third implementation or an integration with an additional geospatial runtime. Both readers share PROJ; the native reader reads the composed USD inputs itself. Neutral export formatting is shared. The original artist asset receives explicit cm/Y-up conformance and an illustrative resize to 300 m before the shown project scale. The figure uses the authored location and heading, then shows the actual footprint before and after the anchor's scale, rotation and translation. Its project-grid origin moves 120 m east and 60 m south, matching the authored adjustment. The coordinate comparison reads every vertex from the two recorded ordinary USD bakes. This is an illustrative placement, not surveyed Paris context. Tower geometry: (FREE) La tour Eiffel, by SDC PERFORMANCE, CC BY 4.0. Asset conformance, size, placement and display are modified in this example; the original archive retains its embedded attribution.</a:t>
             </a:r>
           </a:p>
         </p:txBody>
@@ -1390,7 +1390,7 @@
           <p:cNvPr id="3" name="Title">
             <a:extLst xmlns:a="http://schemas.openxmlformats.org/drawingml/2006/main">
               <a:ext uri="{FF2B5EF4-FFF2-40B4-BE49-F238E27FC236}">
-                <a16:creationId xmlns:a16="http://schemas.microsoft.com/office/drawing/2014/main" id="{76D81167-EE74-4601-BCBF-375B09E395B1}"/>
+                <a16:creationId xmlns:a16="http://schemas.microsoft.com/office/drawing/2014/main" id="{6C8BFA1D-2320-49FF-958C-1A491B913DC9}"/>
               </a:ext>
             </a:extLst>
           </p:cNvPr>
@@ -1619,7 +1619,7 @@
           <p:cNvPr id="2" name="Subtitle">
             <a:extLst xmlns:a="http://schemas.openxmlformats.org/drawingml/2006/main">
               <a:ext uri="{FF2B5EF4-FFF2-40B4-BE49-F238E27FC236}">
-                <a16:creationId xmlns:a16="http://schemas.microsoft.com/office/drawing/2014/main" id="{B5CEC21F-7448-48B6-927D-677E93AB717B}"/>
+                <a16:creationId xmlns:a16="http://schemas.microsoft.com/office/drawing/2014/main" id="{51B774E4-EDAE-4E25-B7B7-ABCFB1017675}"/>
               </a:ext>
             </a:extLst>
           </p:cNvPr>
@@ -1865,7 +1865,7 @@
           <p:cNvPr id="2" name="Section title">
             <a:extLst xmlns:a="http://schemas.openxmlformats.org/drawingml/2006/main">
               <a:ext uri="{FF2B5EF4-FFF2-40B4-BE49-F238E27FC236}">
-                <a16:creationId xmlns:a16="http://schemas.microsoft.com/office/drawing/2014/main" id="{FB8968FC-560F-4430-8CA8-97012A7A807B}"/>
+                <a16:creationId xmlns:a16="http://schemas.microsoft.com/office/drawing/2014/main" id="{C897672C-2B66-4A62-9763-A1380F48F760}"/>
               </a:ext>
             </a:extLst>
           </p:cNvPr>
@@ -2111,7 +2111,7 @@
           <p:cNvPr id="3" name="Title">
             <a:extLst xmlns:a="http://schemas.openxmlformats.org/drawingml/2006/main">
               <a:ext uri="{FF2B5EF4-FFF2-40B4-BE49-F238E27FC236}">
-                <a16:creationId xmlns:a16="http://schemas.microsoft.com/office/drawing/2014/main" id="{8A33D1B2-9157-409E-BC82-044B64F854F6}"/>
+                <a16:creationId xmlns:a16="http://schemas.microsoft.com/office/drawing/2014/main" id="{57A28E2E-CEF8-4218-9F23-06282B04B26E}"/>
               </a:ext>
             </a:extLst>
           </p:cNvPr>
@@ -2340,7 +2340,7 @@
           <p:cNvPr id="2" name="Body">
             <a:extLst xmlns:a="http://schemas.openxmlformats.org/drawingml/2006/main">
               <a:ext uri="{FF2B5EF4-FFF2-40B4-BE49-F238E27FC236}">
-                <a16:creationId xmlns:a16="http://schemas.microsoft.com/office/drawing/2014/main" id="{9885C725-D8D8-4349-9129-CA908774FD8C}"/>
+                <a16:creationId xmlns:a16="http://schemas.microsoft.com/office/drawing/2014/main" id="{02EEFE63-497B-44D0-AB4C-B0142EE5C3E4}"/>
               </a:ext>
             </a:extLst>
           </p:cNvPr>
@@ -2586,7 +2586,7 @@
           <p:cNvPr id="4" name="Title">
             <a:extLst xmlns:a="http://schemas.openxmlformats.org/drawingml/2006/main">
               <a:ext uri="{FF2B5EF4-FFF2-40B4-BE49-F238E27FC236}">
-                <a16:creationId xmlns:a16="http://schemas.microsoft.com/office/drawing/2014/main" id="{6495CF75-391E-4468-A142-9E2E17BDA719}"/>
+                <a16:creationId xmlns:a16="http://schemas.microsoft.com/office/drawing/2014/main" id="{87AA3571-C2CD-449F-83BF-7EE8517A7AF1}"/>
               </a:ext>
             </a:extLst>
           </p:cNvPr>
@@ -2815,7 +2815,7 @@
           <p:cNvPr id="2" name="Left column">
             <a:extLst xmlns:a="http://schemas.openxmlformats.org/drawingml/2006/main">
               <a:ext uri="{FF2B5EF4-FFF2-40B4-BE49-F238E27FC236}">
-                <a16:creationId xmlns:a16="http://schemas.microsoft.com/office/drawing/2014/main" id="{3EE09C55-8431-4070-B1DB-D63CC5C02F38}"/>
+                <a16:creationId xmlns:a16="http://schemas.microsoft.com/office/drawing/2014/main" id="{471CF9A0-C58A-4374-A76A-1D912541DFC0}"/>
               </a:ext>
             </a:extLst>
           </p:cNvPr>
@@ -3044,7 +3044,7 @@
           <p:cNvPr id="3" name="Right column">
             <a:extLst xmlns:a="http://schemas.openxmlformats.org/drawingml/2006/main">
               <a:ext uri="{FF2B5EF4-FFF2-40B4-BE49-F238E27FC236}">
-                <a16:creationId xmlns:a16="http://schemas.microsoft.com/office/drawing/2014/main" id="{10D48AD4-3FB8-4785-B345-4DE8545E3A77}"/>
+                <a16:creationId xmlns:a16="http://schemas.microsoft.com/office/drawing/2014/main" id="{9591B2C1-AE4F-496B-B69A-9E37873BCDCF}"/>
               </a:ext>
             </a:extLst>
           </p:cNvPr>
@@ -3290,7 +3290,7 @@
           <p:cNvPr id="3" name="Title">
             <a:extLst xmlns:a="http://schemas.openxmlformats.org/drawingml/2006/main">
               <a:ext uri="{FF2B5EF4-FFF2-40B4-BE49-F238E27FC236}">
-                <a16:creationId xmlns:a16="http://schemas.microsoft.com/office/drawing/2014/main" id="{FFCF0098-C28B-4972-BFD5-594D648CE696}"/>
+                <a16:creationId xmlns:a16="http://schemas.microsoft.com/office/drawing/2014/main" id="{30C855A4-7B46-48E0-BA15-12D1E10B0F35}"/>
               </a:ext>
             </a:extLst>
           </p:cNvPr>
@@ -3519,7 +3519,7 @@
           <p:cNvPr id="2" name="Left column">
             <a:extLst xmlns:a="http://schemas.openxmlformats.org/drawingml/2006/main">
               <a:ext uri="{FF2B5EF4-FFF2-40B4-BE49-F238E27FC236}">
-                <a16:creationId xmlns:a16="http://schemas.microsoft.com/office/drawing/2014/main" id="{6676FA50-5F8C-4BAC-994F-CB47A63C84CA}"/>
+                <a16:creationId xmlns:a16="http://schemas.microsoft.com/office/drawing/2014/main" id="{AD9F0110-654A-415F-B9AF-5FE7F93647CA}"/>
               </a:ext>
             </a:extLst>
           </p:cNvPr>
@@ -3786,12 +3786,12 @@
   </p:cSld>
   <p:clrMap bg1="lt1" tx1="dk1" bg2="lt2" tx2="dk2" accent1="accent1" accent2="accent2" accent3="accent3" accent4="accent4" accent5="accent5" accent6="accent6" hlink="hlink" folHlink="folHlink"/>
   <p:sldLayoutIdLst>
-    <p:sldLayoutId xmlns:r="http://schemas.openxmlformats.org/officeDocument/2006/relationships" id="2147483649" r:id="R3e489b236a964c18"/>
-    <p:sldLayoutId xmlns:r="http://schemas.openxmlformats.org/officeDocument/2006/relationships" id="2147483650" r:id="Rcdf0e0e8a0b342e1"/>
-    <p:sldLayoutId xmlns:r="http://schemas.openxmlformats.org/officeDocument/2006/relationships" id="2147483651" r:id="Rd58a9ccb3c3d4b94"/>
-    <p:sldLayoutId xmlns:r="http://schemas.openxmlformats.org/officeDocument/2006/relationships" id="2147483652" r:id="R50a514cad9e14df4"/>
-    <p:sldLayoutId xmlns:r="http://schemas.openxmlformats.org/officeDocument/2006/relationships" id="2147483653" r:id="R763a9b469898481f"/>
-    <p:sldLayoutId xmlns:r="http://schemas.openxmlformats.org/officeDocument/2006/relationships" id="2147483654" r:id="Rbb97ce4ca963403a"/>
+    <p:sldLayoutId xmlns:r="http://schemas.openxmlformats.org/officeDocument/2006/relationships" id="2147483649" r:id="Re06be7015cac48b2"/>
+    <p:sldLayoutId xmlns:r="http://schemas.openxmlformats.org/officeDocument/2006/relationships" id="2147483650" r:id="R949dd98485924d1e"/>
+    <p:sldLayoutId xmlns:r="http://schemas.openxmlformats.org/officeDocument/2006/relationships" id="2147483651" r:id="Rbe95201c25014101"/>
+    <p:sldLayoutId xmlns:r="http://schemas.openxmlformats.org/officeDocument/2006/relationships" id="2147483652" r:id="R96e0f48ca2ca4ac3"/>
+    <p:sldLayoutId xmlns:r="http://schemas.openxmlformats.org/officeDocument/2006/relationships" id="2147483653" r:id="Rd83707fa1bbb4ebe"/>
+    <p:sldLayoutId xmlns:r="http://schemas.openxmlformats.org/officeDocument/2006/relationships" id="2147483654" r:id="R17a72c36b2c24488"/>
   </p:sldLayoutIdLst>
   <p:txStyles>
     <p:titleStyle>
@@ -4342,7 +4342,7 @@
           <p:cNvPr id="5" name="">
             <a:extLst xmlns:a="http://schemas.openxmlformats.org/drawingml/2006/main">
               <a:ext uri="{FF2B5EF4-FFF2-40B4-BE49-F238E27FC236}">
-                <a16:creationId xmlns:a16="http://schemas.microsoft.com/office/drawing/2014/main" id="{6480605B-6513-4C76-AC1E-2981C7C77F98}"/>
+                <a16:creationId xmlns:a16="http://schemas.microsoft.com/office/drawing/2014/main" id="{FFD55C80-0AA7-4854-BDDB-C125C0E77A63}"/>
               </a:ext>
             </a:extLst>
           </p:cNvPr>
@@ -4500,7 +4500,7 @@
           <p:cNvPr id="2" name="">
             <a:extLst xmlns:a="http://schemas.openxmlformats.org/drawingml/2006/main">
               <a:ext uri="{FF2B5EF4-FFF2-40B4-BE49-F238E27FC236}">
-                <a16:creationId xmlns:a16="http://schemas.microsoft.com/office/drawing/2014/main" id="{97DA7CD6-F135-4655-9D58-D9A5EAFB7B9A}"/>
+                <a16:creationId xmlns:a16="http://schemas.microsoft.com/office/drawing/2014/main" id="{506FD4B2-4E72-4015-ACA0-BE1B082E404F}"/>
               </a:ext>
             </a:extLst>
           </p:cNvPr>
@@ -4658,7 +4658,7 @@
           <p:cNvPr id="3" name="">
             <a:extLst xmlns:a="http://schemas.openxmlformats.org/drawingml/2006/main">
               <a:ext uri="{FF2B5EF4-FFF2-40B4-BE49-F238E27FC236}">
-                <a16:creationId xmlns:a16="http://schemas.microsoft.com/office/drawing/2014/main" id="{300DEFB2-272D-489E-927B-21CD929E6A43}"/>
+                <a16:creationId xmlns:a16="http://schemas.microsoft.com/office/drawing/2014/main" id="{AA2B1EB1-E7AC-4F6E-AA8D-69EEE2DB7762}"/>
               </a:ext>
             </a:extLst>
           </p:cNvPr>
@@ -4816,7 +4816,7 @@
           <p:cNvPr id="4" name="">
             <a:extLst xmlns:a="http://schemas.openxmlformats.org/drawingml/2006/main">
               <a:ext uri="{FF2B5EF4-FFF2-40B4-BE49-F238E27FC236}">
-                <a16:creationId xmlns:a16="http://schemas.microsoft.com/office/drawing/2014/main" id="{8B1A0FE1-FADF-4D33-8592-3310FED0C8CE}"/>
+                <a16:creationId xmlns:a16="http://schemas.microsoft.com/office/drawing/2014/main" id="{B813C238-B552-4871-AA61-DA474ED69801}"/>
               </a:ext>
             </a:extLst>
           </p:cNvPr>
@@ -4972,7 +4972,7 @@
     </p:spTree>
     <p:extLst>
       <p:ext uri="{BB962C8B-B14F-4D97-AF65-F5344CB8AC3E}">
-        <p14:creationId xmlns:p14="http://schemas.microsoft.com/office/powerpoint/2010/main" val="2084196211"/>
+        <p14:creationId xmlns:p14="http://schemas.microsoft.com/office/powerpoint/2010/main" val="253785360"/>
       </p:ext>
     </p:extLst>
   </p:cSld>
@@ -5003,7 +5003,7 @@
           <p:cNvPr id="6" name="">
             <a:extLst xmlns:a="http://schemas.openxmlformats.org/drawingml/2006/main">
               <a:ext uri="{FF2B5EF4-FFF2-40B4-BE49-F238E27FC236}">
-                <a16:creationId xmlns:a16="http://schemas.microsoft.com/office/drawing/2014/main" id="{B5E3B184-5CA4-4E56-9ADD-FB9322594F72}"/>
+                <a16:creationId xmlns:a16="http://schemas.microsoft.com/office/drawing/2014/main" id="{F28E0A50-8A3E-4BD7-A10E-91574D94834B}"/>
               </a:ext>
             </a:extLst>
           </p:cNvPr>
@@ -5161,7 +5161,7 @@
           <p:cNvPr id="2" name="">
             <a:extLst xmlns:a="http://schemas.openxmlformats.org/drawingml/2006/main">
               <a:ext uri="{FF2B5EF4-FFF2-40B4-BE49-F238E27FC236}">
-                <a16:creationId xmlns:a16="http://schemas.microsoft.com/office/drawing/2014/main" id="{B7368441-3616-421E-8ABA-0CD7F5866C50}"/>
+                <a16:creationId xmlns:a16="http://schemas.microsoft.com/office/drawing/2014/main" id="{C42307FB-4DDB-4E19-ABEC-6EDA8F62355C}"/>
               </a:ext>
             </a:extLst>
           </p:cNvPr>
@@ -5319,7 +5319,7 @@
           <p:cNvPr id="3" name="">
             <a:extLst xmlns:a="http://schemas.openxmlformats.org/drawingml/2006/main">
               <a:ext uri="{FF2B5EF4-FFF2-40B4-BE49-F238E27FC236}">
-                <a16:creationId xmlns:a16="http://schemas.microsoft.com/office/drawing/2014/main" id="{695DA1D9-AC50-4E67-A3E5-FED8B04E5E24}"/>
+                <a16:creationId xmlns:a16="http://schemas.microsoft.com/office/drawing/2014/main" id="{6902171C-939E-4CC9-AF74-98AA03045FD6}"/>
               </a:ext>
             </a:extLst>
           </p:cNvPr>
@@ -5779,7 +5779,7 @@
           <p:cNvPr id="4" name="">
             <a:extLst xmlns:a="http://schemas.openxmlformats.org/drawingml/2006/main">
               <a:ext uri="{FF2B5EF4-FFF2-40B4-BE49-F238E27FC236}">
-                <a16:creationId xmlns:a16="http://schemas.microsoft.com/office/drawing/2014/main" id="{C975BB39-6F13-4CD1-B19A-8F178520D62B}"/>
+                <a16:creationId xmlns:a16="http://schemas.microsoft.com/office/drawing/2014/main" id="{0B484C9C-FD3D-47B8-8421-92FA840255C1}"/>
               </a:ext>
             </a:extLst>
           </p:cNvPr>
@@ -5937,7 +5937,7 @@
           <p:cNvPr id="5" name="">
             <a:extLst xmlns:a="http://schemas.openxmlformats.org/drawingml/2006/main">
               <a:ext uri="{FF2B5EF4-FFF2-40B4-BE49-F238E27FC236}">
-                <a16:creationId xmlns:a16="http://schemas.microsoft.com/office/drawing/2014/main" id="{B2E6B520-66A1-4105-8AC5-5F2ACEE9A72F}"/>
+                <a16:creationId xmlns:a16="http://schemas.microsoft.com/office/drawing/2014/main" id="{7E3FDC97-E072-47E3-AF3C-FE0A38D85200}"/>
               </a:ext>
             </a:extLst>
           </p:cNvPr>
@@ -6093,7 +6093,7 @@
     </p:spTree>
     <p:extLst>
       <p:ext uri="{BB962C8B-B14F-4D97-AF65-F5344CB8AC3E}">
-        <p14:creationId xmlns:p14="http://schemas.microsoft.com/office/powerpoint/2010/main" val="2038104939"/>
+        <p14:creationId xmlns:p14="http://schemas.microsoft.com/office/powerpoint/2010/main" val="1528360649"/>
       </p:ext>
     </p:extLst>
   </p:cSld>
@@ -6124,7 +6124,7 @@
           <p:cNvPr id="6" name="">
             <a:extLst xmlns:a="http://schemas.openxmlformats.org/drawingml/2006/main">
               <a:ext uri="{FF2B5EF4-FFF2-40B4-BE49-F238E27FC236}">
-                <a16:creationId xmlns:a16="http://schemas.microsoft.com/office/drawing/2014/main" id="{61D6A812-F8CD-446D-98F3-72E08CBF6179}"/>
+                <a16:creationId xmlns:a16="http://schemas.microsoft.com/office/drawing/2014/main" id="{A8305455-8DE5-4C7B-ABD7-DC06E4BE1ADE}"/>
               </a:ext>
             </a:extLst>
           </p:cNvPr>
@@ -6282,7 +6282,7 @@
           <p:cNvPr id="2" name="">
             <a:extLst xmlns:a="http://schemas.openxmlformats.org/drawingml/2006/main">
               <a:ext uri="{FF2B5EF4-FFF2-40B4-BE49-F238E27FC236}">
-                <a16:creationId xmlns:a16="http://schemas.microsoft.com/office/drawing/2014/main" id="{C0E60968-CF2E-413A-804E-C577B44233BB}"/>
+                <a16:creationId xmlns:a16="http://schemas.microsoft.com/office/drawing/2014/main" id="{50F0FDE9-09AC-4578-AF56-5FA0F9AA7C3B}"/>
               </a:ext>
             </a:extLst>
           </p:cNvPr>
@@ -6440,7 +6440,7 @@
           <p:cNvPr id="3" name="">
             <a:extLst xmlns:a="http://schemas.openxmlformats.org/drawingml/2006/main">
               <a:ext uri="{FF2B5EF4-FFF2-40B4-BE49-F238E27FC236}">
-                <a16:creationId xmlns:a16="http://schemas.microsoft.com/office/drawing/2014/main" id="{3EB625C0-3647-4110-A7A7-D5628AEB69D7}"/>
+                <a16:creationId xmlns:a16="http://schemas.microsoft.com/office/drawing/2014/main" id="{F279D487-9CCA-4359-A86C-055EF875AC95}"/>
               </a:ext>
             </a:extLst>
           </p:cNvPr>
@@ -6450,7 +6450,7 @@
           <p:nvPr/>
         </p:nvPicPr>
         <p:blipFill>
-          <a:blip xmlns:r="http://schemas.openxmlformats.org/officeDocument/2006/relationships" xmlns:a="http://schemas.openxmlformats.org/drawingml/2006/main" r:embed="R443e8ad437bf4c68"/>
+          <a:blip xmlns:r="http://schemas.openxmlformats.org/officeDocument/2006/relationships" xmlns:a="http://schemas.openxmlformats.org/drawingml/2006/main" r:embed="Ra4e32172916f451f"/>
           <a:stretch xmlns:a="http://schemas.openxmlformats.org/drawingml/2006/main"/>
         </p:blipFill>
         <p:spPr>
@@ -6468,7 +6468,7 @@
           <p:cNvPr id="4" name="">
             <a:extLst xmlns:a="http://schemas.openxmlformats.org/drawingml/2006/main">
               <a:ext uri="{FF2B5EF4-FFF2-40B4-BE49-F238E27FC236}">
-                <a16:creationId xmlns:a16="http://schemas.microsoft.com/office/drawing/2014/main" id="{4A9588A0-3A8B-4BDD-BF4B-7CDEFE9BCD12}"/>
+                <a16:creationId xmlns:a16="http://schemas.microsoft.com/office/drawing/2014/main" id="{72B54DB1-5DF7-40FD-8E6D-7313D99FA4BA}"/>
               </a:ext>
             </a:extLst>
           </p:cNvPr>
@@ -6626,7 +6626,7 @@
           <p:cNvPr id="5" name="">
             <a:extLst xmlns:a="http://schemas.openxmlformats.org/drawingml/2006/main">
               <a:ext uri="{FF2B5EF4-FFF2-40B4-BE49-F238E27FC236}">
-                <a16:creationId xmlns:a16="http://schemas.microsoft.com/office/drawing/2014/main" id="{2703B6A2-7B77-490A-87B9-A840EB508067}"/>
+                <a16:creationId xmlns:a16="http://schemas.microsoft.com/office/drawing/2014/main" id="{009CFFBF-4D85-44B8-A0D2-3D10CE6F5088}"/>
               </a:ext>
             </a:extLst>
           </p:cNvPr>
@@ -6782,7 +6782,7 @@
     </p:spTree>
     <p:extLst>
       <p:ext uri="{BB962C8B-B14F-4D97-AF65-F5344CB8AC3E}">
-        <p14:creationId xmlns:p14="http://schemas.microsoft.com/office/powerpoint/2010/main" val="611032169"/>
+        <p14:creationId xmlns:p14="http://schemas.microsoft.com/office/powerpoint/2010/main" val="1060709403"/>
       </p:ext>
     </p:extLst>
   </p:cSld>
@@ -6813,7 +6813,7 @@
           <p:cNvPr id="6" name="">
             <a:extLst xmlns:a="http://schemas.openxmlformats.org/drawingml/2006/main">
               <a:ext uri="{FF2B5EF4-FFF2-40B4-BE49-F238E27FC236}">
-                <a16:creationId xmlns:a16="http://schemas.microsoft.com/office/drawing/2014/main" id="{66FF92B2-B43E-45B1-9A4C-54207D18ABA9}"/>
+                <a16:creationId xmlns:a16="http://schemas.microsoft.com/office/drawing/2014/main" id="{5A4E831F-40C2-41E2-8989-0427067967EF}"/>
               </a:ext>
             </a:extLst>
           </p:cNvPr>
@@ -6971,7 +6971,7 @@
           <p:cNvPr id="2" name="">
             <a:extLst xmlns:a="http://schemas.openxmlformats.org/drawingml/2006/main">
               <a:ext uri="{FF2B5EF4-FFF2-40B4-BE49-F238E27FC236}">
-                <a16:creationId xmlns:a16="http://schemas.microsoft.com/office/drawing/2014/main" id="{C8EC6333-8D44-4AEF-862C-B130EB42915B}"/>
+                <a16:creationId xmlns:a16="http://schemas.microsoft.com/office/drawing/2014/main" id="{C692ABEA-3CDE-45DF-9A72-FF82A31E9642}"/>
               </a:ext>
             </a:extLst>
           </p:cNvPr>
@@ -7129,7 +7129,7 @@
           <p:cNvPr id="3" name="">
             <a:extLst xmlns:a="http://schemas.openxmlformats.org/drawingml/2006/main">
               <a:ext uri="{FF2B5EF4-FFF2-40B4-BE49-F238E27FC236}">
-                <a16:creationId xmlns:a16="http://schemas.microsoft.com/office/drawing/2014/main" id="{39BC91A6-DDFB-44DE-B498-ABFB41700F3E}"/>
+                <a16:creationId xmlns:a16="http://schemas.microsoft.com/office/drawing/2014/main" id="{C6F6CC0C-FCCE-45E6-AF47-6BA5AFAA7FDB}"/>
               </a:ext>
             </a:extLst>
           </p:cNvPr>
@@ -7673,7 +7673,7 @@
           <p:cNvPr id="4" name="">
             <a:extLst xmlns:a="http://schemas.openxmlformats.org/drawingml/2006/main">
               <a:ext uri="{FF2B5EF4-FFF2-40B4-BE49-F238E27FC236}">
-                <a16:creationId xmlns:a16="http://schemas.microsoft.com/office/drawing/2014/main" id="{E329DAEA-263D-40CD-9653-F7FE2795442F}"/>
+                <a16:creationId xmlns:a16="http://schemas.microsoft.com/office/drawing/2014/main" id="{D859A4D2-5179-4E75-8AA8-52755D643BF1}"/>
               </a:ext>
             </a:extLst>
           </p:cNvPr>
@@ -7831,7 +7831,7 @@
           <p:cNvPr id="5" name="">
             <a:extLst xmlns:a="http://schemas.openxmlformats.org/drawingml/2006/main">
               <a:ext uri="{FF2B5EF4-FFF2-40B4-BE49-F238E27FC236}">
-                <a16:creationId xmlns:a16="http://schemas.microsoft.com/office/drawing/2014/main" id="{A7589886-33A8-40CF-8821-7DEB82297F59}"/>
+                <a16:creationId xmlns:a16="http://schemas.microsoft.com/office/drawing/2014/main" id="{4F1DB4E7-B67C-4BA0-A909-BCC899C4F2AF}"/>
               </a:ext>
             </a:extLst>
           </p:cNvPr>
@@ -7987,7 +7987,7 @@
     </p:spTree>
     <p:extLst>
       <p:ext uri="{BB962C8B-B14F-4D97-AF65-F5344CB8AC3E}">
-        <p14:creationId xmlns:p14="http://schemas.microsoft.com/office/powerpoint/2010/main" val="568505849"/>
+        <p14:creationId xmlns:p14="http://schemas.microsoft.com/office/powerpoint/2010/main" val="575904652"/>
       </p:ext>
     </p:extLst>
   </p:cSld>
@@ -8018,7 +8018,7 @@
           <p:cNvPr id="6" name="">
             <a:extLst xmlns:a="http://schemas.openxmlformats.org/drawingml/2006/main">
               <a:ext uri="{FF2B5EF4-FFF2-40B4-BE49-F238E27FC236}">
-                <a16:creationId xmlns:a16="http://schemas.microsoft.com/office/drawing/2014/main" id="{54FE6FD7-0D81-4E52-95E5-7EE84AB35609}"/>
+                <a16:creationId xmlns:a16="http://schemas.microsoft.com/office/drawing/2014/main" id="{B485C007-AACE-452F-A443-8FAA75544E58}"/>
               </a:ext>
             </a:extLst>
           </p:cNvPr>
@@ -8176,7 +8176,7 @@
           <p:cNvPr id="2" name="">
             <a:extLst xmlns:a="http://schemas.openxmlformats.org/drawingml/2006/main">
               <a:ext uri="{FF2B5EF4-FFF2-40B4-BE49-F238E27FC236}">
-                <a16:creationId xmlns:a16="http://schemas.microsoft.com/office/drawing/2014/main" id="{7B42F0D3-91B2-487B-A1D2-466B1C851CE2}"/>
+                <a16:creationId xmlns:a16="http://schemas.microsoft.com/office/drawing/2014/main" id="{457ECE9B-4DEF-49FB-AFA6-6A6437DBD72C}"/>
               </a:ext>
             </a:extLst>
           </p:cNvPr>
@@ -8334,7 +8334,7 @@
           <p:cNvPr id="3" name="">
             <a:extLst xmlns:a="http://schemas.openxmlformats.org/drawingml/2006/main">
               <a:ext uri="{FF2B5EF4-FFF2-40B4-BE49-F238E27FC236}">
-                <a16:creationId xmlns:a16="http://schemas.microsoft.com/office/drawing/2014/main" id="{17999B84-0DC4-414A-81DA-29931EF03515}"/>
+                <a16:creationId xmlns:a16="http://schemas.microsoft.com/office/drawing/2014/main" id="{900ED014-09D7-4B99-9726-5EC2A0690667}"/>
               </a:ext>
             </a:extLst>
           </p:cNvPr>
@@ -8878,7 +8878,7 @@
           <p:cNvPr id="4" name="">
             <a:extLst xmlns:a="http://schemas.openxmlformats.org/drawingml/2006/main">
               <a:ext uri="{FF2B5EF4-FFF2-40B4-BE49-F238E27FC236}">
-                <a16:creationId xmlns:a16="http://schemas.microsoft.com/office/drawing/2014/main" id="{2E813A48-B072-4096-B426-7E256192063E}"/>
+                <a16:creationId xmlns:a16="http://schemas.microsoft.com/office/drawing/2014/main" id="{A67B27C0-F507-4821-BA8F-FFF6B0EADE84}"/>
               </a:ext>
             </a:extLst>
           </p:cNvPr>
@@ -9036,7 +9036,7 @@
           <p:cNvPr id="5" name="">
             <a:extLst xmlns:a="http://schemas.openxmlformats.org/drawingml/2006/main">
               <a:ext uri="{FF2B5EF4-FFF2-40B4-BE49-F238E27FC236}">
-                <a16:creationId xmlns:a16="http://schemas.microsoft.com/office/drawing/2014/main" id="{0FFD0BCA-9F72-41CA-A410-3AC43AA46141}"/>
+                <a16:creationId xmlns:a16="http://schemas.microsoft.com/office/drawing/2014/main" id="{5AAFD988-6E50-493E-A617-263253ED21AC}"/>
               </a:ext>
             </a:extLst>
           </p:cNvPr>
@@ -9192,7 +9192,7 @@
     </p:spTree>
     <p:extLst>
       <p:ext uri="{BB962C8B-B14F-4D97-AF65-F5344CB8AC3E}">
-        <p14:creationId xmlns:p14="http://schemas.microsoft.com/office/powerpoint/2010/main" val="1456209442"/>
+        <p14:creationId xmlns:p14="http://schemas.microsoft.com/office/powerpoint/2010/main" val="922743514"/>
       </p:ext>
     </p:extLst>
   </p:cSld>
@@ -9223,7 +9223,7 @@
           <p:cNvPr id="6" name="">
             <a:extLst xmlns:a="http://schemas.openxmlformats.org/drawingml/2006/main">
               <a:ext uri="{FF2B5EF4-FFF2-40B4-BE49-F238E27FC236}">
-                <a16:creationId xmlns:a16="http://schemas.microsoft.com/office/drawing/2014/main" id="{8A157558-E3F3-4711-BF85-E1B727B41A97}"/>
+                <a16:creationId xmlns:a16="http://schemas.microsoft.com/office/drawing/2014/main" id="{799C754B-5764-48DB-A50F-CD4B74C1E703}"/>
               </a:ext>
             </a:extLst>
           </p:cNvPr>
@@ -9381,7 +9381,7 @@
           <p:cNvPr id="2" name="">
             <a:extLst xmlns:a="http://schemas.openxmlformats.org/drawingml/2006/main">
               <a:ext uri="{FF2B5EF4-FFF2-40B4-BE49-F238E27FC236}">
-                <a16:creationId xmlns:a16="http://schemas.microsoft.com/office/drawing/2014/main" id="{2B10532F-31EB-4A5E-B480-BF9576227C9C}"/>
+                <a16:creationId xmlns:a16="http://schemas.microsoft.com/office/drawing/2014/main" id="{DB3A6075-659F-4517-B314-21626C27809C}"/>
               </a:ext>
             </a:extLst>
           </p:cNvPr>
@@ -9539,7 +9539,7 @@
           <p:cNvPr id="3" name="">
             <a:extLst xmlns:a="http://schemas.openxmlformats.org/drawingml/2006/main">
               <a:ext uri="{FF2B5EF4-FFF2-40B4-BE49-F238E27FC236}">
-                <a16:creationId xmlns:a16="http://schemas.microsoft.com/office/drawing/2014/main" id="{DE9D310E-8479-4E68-8446-D65EC79944DD}"/>
+                <a16:creationId xmlns:a16="http://schemas.microsoft.com/office/drawing/2014/main" id="{CD9B3D1B-ADE1-42AD-AB85-470AA948AD77}"/>
               </a:ext>
             </a:extLst>
           </p:cNvPr>
@@ -10083,7 +10083,7 @@
           <p:cNvPr id="4" name="">
             <a:extLst xmlns:a="http://schemas.openxmlformats.org/drawingml/2006/main">
               <a:ext uri="{FF2B5EF4-FFF2-40B4-BE49-F238E27FC236}">
-                <a16:creationId xmlns:a16="http://schemas.microsoft.com/office/drawing/2014/main" id="{1D9DFED6-9F22-42FF-95ED-4693735AC854}"/>
+                <a16:creationId xmlns:a16="http://schemas.microsoft.com/office/drawing/2014/main" id="{445CC065-27BF-43E1-BC3C-B4271BB85926}"/>
               </a:ext>
             </a:extLst>
           </p:cNvPr>
@@ -10241,7 +10241,7 @@
           <p:cNvPr id="5" name="">
             <a:extLst xmlns:a="http://schemas.openxmlformats.org/drawingml/2006/main">
               <a:ext uri="{FF2B5EF4-FFF2-40B4-BE49-F238E27FC236}">
-                <a16:creationId xmlns:a16="http://schemas.microsoft.com/office/drawing/2014/main" id="{81B72CFA-E822-4F6E-970A-03F2EC94CB80}"/>
+                <a16:creationId xmlns:a16="http://schemas.microsoft.com/office/drawing/2014/main" id="{ADE74867-4891-4D15-8092-A19449042D70}"/>
               </a:ext>
             </a:extLst>
           </p:cNvPr>
@@ -10397,7 +10397,7 @@
     </p:spTree>
     <p:extLst>
       <p:ext uri="{BB962C8B-B14F-4D97-AF65-F5344CB8AC3E}">
-        <p14:creationId xmlns:p14="http://schemas.microsoft.com/office/powerpoint/2010/main" val="1892836787"/>
+        <p14:creationId xmlns:p14="http://schemas.microsoft.com/office/powerpoint/2010/main" val="807527699"/>
       </p:ext>
     </p:extLst>
   </p:cSld>
@@ -10428,7 +10428,7 @@
           <p:cNvPr id="6" name="">
             <a:extLst xmlns:a="http://schemas.openxmlformats.org/drawingml/2006/main">
               <a:ext uri="{FF2B5EF4-FFF2-40B4-BE49-F238E27FC236}">
-                <a16:creationId xmlns:a16="http://schemas.microsoft.com/office/drawing/2014/main" id="{FF815633-64E4-4AFC-9B1A-348AA2D4AD61}"/>
+                <a16:creationId xmlns:a16="http://schemas.microsoft.com/office/drawing/2014/main" id="{8986CFB1-B6C3-4D20-8C71-D8A32FB5C31E}"/>
               </a:ext>
             </a:extLst>
           </p:cNvPr>
@@ -10586,7 +10586,7 @@
           <p:cNvPr id="2" name="">
             <a:extLst xmlns:a="http://schemas.openxmlformats.org/drawingml/2006/main">
               <a:ext uri="{FF2B5EF4-FFF2-40B4-BE49-F238E27FC236}">
-                <a16:creationId xmlns:a16="http://schemas.microsoft.com/office/drawing/2014/main" id="{0B930C22-FE71-4CF0-99DC-6D46920A56C7}"/>
+                <a16:creationId xmlns:a16="http://schemas.microsoft.com/office/drawing/2014/main" id="{9AEBF790-83B7-4AC3-80C3-2BEC85CA9E13}"/>
               </a:ext>
             </a:extLst>
           </p:cNvPr>
@@ -10744,7 +10744,7 @@
           <p:cNvPr id="3" name="">
             <a:extLst xmlns:a="http://schemas.openxmlformats.org/drawingml/2006/main">
               <a:ext uri="{FF2B5EF4-FFF2-40B4-BE49-F238E27FC236}">
-                <a16:creationId xmlns:a16="http://schemas.microsoft.com/office/drawing/2014/main" id="{5CC4F4EB-29C5-4BD3-B564-5989FDA65024}"/>
+                <a16:creationId xmlns:a16="http://schemas.microsoft.com/office/drawing/2014/main" id="{765D9247-574D-4930-AB0C-85E8D92669D4}"/>
               </a:ext>
             </a:extLst>
           </p:cNvPr>
@@ -11279,7 +11279,7 @@
           <p:cNvPr id="4" name="">
             <a:extLst xmlns:a="http://schemas.openxmlformats.org/drawingml/2006/main">
               <a:ext uri="{FF2B5EF4-FFF2-40B4-BE49-F238E27FC236}">
-                <a16:creationId xmlns:a16="http://schemas.microsoft.com/office/drawing/2014/main" id="{9357B286-8099-4C17-9C4F-D2F61F1D3D88}"/>
+                <a16:creationId xmlns:a16="http://schemas.microsoft.com/office/drawing/2014/main" id="{77D6E070-CF23-4C8F-B162-74F35A1B8547}"/>
               </a:ext>
             </a:extLst>
           </p:cNvPr>
@@ -11437,7 +11437,7 @@
           <p:cNvPr id="5" name="">
             <a:extLst xmlns:a="http://schemas.openxmlformats.org/drawingml/2006/main">
               <a:ext uri="{FF2B5EF4-FFF2-40B4-BE49-F238E27FC236}">
-                <a16:creationId xmlns:a16="http://schemas.microsoft.com/office/drawing/2014/main" id="{4EB2E5D9-799C-4E4B-947A-47FD17987739}"/>
+                <a16:creationId xmlns:a16="http://schemas.microsoft.com/office/drawing/2014/main" id="{B178B284-4A8A-4B3B-9DD9-02C68584E23D}"/>
               </a:ext>
             </a:extLst>
           </p:cNvPr>
@@ -11593,7 +11593,7 @@
     </p:spTree>
     <p:extLst>
       <p:ext uri="{BB962C8B-B14F-4D97-AF65-F5344CB8AC3E}">
-        <p14:creationId xmlns:p14="http://schemas.microsoft.com/office/powerpoint/2010/main" val="1221843421"/>
+        <p14:creationId xmlns:p14="http://schemas.microsoft.com/office/powerpoint/2010/main" val="1997312482"/>
       </p:ext>
     </p:extLst>
   </p:cSld>
@@ -11621,10 +11621,10 @@
       </p:grpSpPr>
       <p:sp>
         <p:nvSpPr>
-          <p:cNvPr id="6" name="">
+          <p:cNvPr id="5" name="">
             <a:extLst xmlns:a="http://schemas.openxmlformats.org/drawingml/2006/main">
               <a:ext uri="{FF2B5EF4-FFF2-40B4-BE49-F238E27FC236}">
-                <a16:creationId xmlns:a16="http://schemas.microsoft.com/office/drawing/2014/main" id="{BC36FD08-2848-4B80-82C6-8D26DE3EF64A}"/>
+                <a16:creationId xmlns:a16="http://schemas.microsoft.com/office/drawing/2014/main" id="{2E04D28E-6D58-4C23-AF0F-B9299DA008DB}"/>
               </a:ext>
             </a:extLst>
           </p:cNvPr>
@@ -11782,7 +11782,7 @@
           <p:cNvPr id="2" name="">
             <a:extLst xmlns:a="http://schemas.openxmlformats.org/drawingml/2006/main">
               <a:ext uri="{FF2B5EF4-FFF2-40B4-BE49-F238E27FC236}">
-                <a16:creationId xmlns:a16="http://schemas.microsoft.com/office/drawing/2014/main" id="{E08E1530-4492-4E99-BDD6-1348676C95C0}"/>
+                <a16:creationId xmlns:a16="http://schemas.microsoft.com/office/drawing/2014/main" id="{CD3F5056-0625-44C2-8F8C-29CFE13C7036}"/>
               </a:ext>
             </a:extLst>
           </p:cNvPr>
@@ -11792,13 +11792,13 @@
           <p:nvPr/>
         </p:nvPicPr>
         <p:blipFill>
-          <a:blip xmlns:r="http://schemas.openxmlformats.org/officeDocument/2006/relationships" xmlns:a="http://schemas.openxmlformats.org/drawingml/2006/main" r:embed="Ra5b515c8698b4354"/>
+          <a:blip xmlns:r="http://schemas.openxmlformats.org/officeDocument/2006/relationships" xmlns:a="http://schemas.openxmlformats.org/drawingml/2006/main" r:embed="R6af42d70e8c84ec5"/>
           <a:stretch xmlns:a="http://schemas.openxmlformats.org/drawingml/2006/main"/>
         </p:blipFill>
         <p:spPr>
           <a:xfrm xmlns:a="http://schemas.openxmlformats.org/drawingml/2006/main">
-            <a:off x="5562600" y="1524292"/>
-            <a:ext cx="6019800" cy="4390441"/>
+            <a:off x="609600" y="1441132"/>
+            <a:ext cx="10972800" cy="4594860"/>
           </a:xfrm>
           <a:prstGeom xmlns:a="http://schemas.openxmlformats.org/drawingml/2006/main" prst="rect">
             <a:avLst/>
@@ -11810,165 +11810,7 @@
           <p:cNvPr id="3" name="">
             <a:extLst xmlns:a="http://schemas.openxmlformats.org/drawingml/2006/main">
               <a:ext uri="{FF2B5EF4-FFF2-40B4-BE49-F238E27FC236}">
-                <a16:creationId xmlns:a16="http://schemas.microsoft.com/office/drawing/2014/main" id="{21F71FD9-E60E-4B18-AC6E-3C17272255E0}"/>
-              </a:ext>
-            </a:extLst>
-          </p:cNvPr>
-          <p:cNvSpPr>
-            <a:spLocks xmlns:a="http://schemas.openxmlformats.org/drawingml/2006/main" noGrp="1"/>
-          </p:cNvSpPr>
-          <p:nvPr/>
-        </p:nvSpPr>
-        <p:spPr>
-          <a:xfrm xmlns:a="http://schemas.openxmlformats.org/drawingml/2006/main">
-            <a:off x="609600" y="1733550"/>
-            <a:ext cx="4476750" cy="3962400"/>
-          </a:xfrm>
-          <a:prstGeom xmlns:a="http://schemas.openxmlformats.org/drawingml/2006/main" prst="rect">
-            <a:avLst/>
-          </a:prstGeom>
-          <a:noFill xmlns:a="http://schemas.openxmlformats.org/drawingml/2006/main"/>
-          <a:ln xmlns:a="http://schemas.openxmlformats.org/drawingml/2006/main" w="0">
-            <a:noFill/>
-          </a:ln>
-        </p:spPr>
-        <p:txBody>
-          <a:bodyPr xmlns:a="http://schemas.openxmlformats.org/drawingml/2006/main" wrap="square" lIns="0" tIns="0" rIns="0" bIns="0" anchor="t">
-            <a:noAutofit/>
-          </a:bodyPr>
-          <a:lstStyle xmlns:a="http://schemas.openxmlformats.org/drawingml/2006/main">
-            <a:defPPr>
-              <a:defRPr sz="2100" b="0">
-                <a:solidFill>
-                  <a:srgbClr val="284653"/>
-                </a:solidFill>
-                <a:latin typeface="Arial"/>
-                <a:ea typeface="Arial"/>
-                <a:cs typeface="Arial"/>
-              </a:defRPr>
-            </a:defPPr>
-            <a:lvl1pPr>
-              <a:defRPr sz="2100" b="0">
-                <a:solidFill>
-                  <a:srgbClr val="284653"/>
-                </a:solidFill>
-                <a:latin typeface="Arial"/>
-                <a:ea typeface="Arial"/>
-                <a:cs typeface="Arial"/>
-              </a:defRPr>
-            </a:lvl1pPr>
-            <a:lvl2pPr>
-              <a:defRPr sz="2100" b="0">
-                <a:solidFill>
-                  <a:srgbClr val="284653"/>
-                </a:solidFill>
-                <a:latin typeface="Arial"/>
-                <a:ea typeface="Arial"/>
-                <a:cs typeface="Arial"/>
-              </a:defRPr>
-            </a:lvl2pPr>
-            <a:lvl3pPr>
-              <a:defRPr sz="2100" b="0">
-                <a:solidFill>
-                  <a:srgbClr val="284653"/>
-                </a:solidFill>
-                <a:latin typeface="Arial"/>
-                <a:ea typeface="Arial"/>
-                <a:cs typeface="Arial"/>
-              </a:defRPr>
-            </a:lvl3pPr>
-            <a:lvl4pPr>
-              <a:defRPr sz="2100" b="0">
-                <a:solidFill>
-                  <a:srgbClr val="284653"/>
-                </a:solidFill>
-                <a:latin typeface="Arial"/>
-                <a:ea typeface="Arial"/>
-                <a:cs typeface="Arial"/>
-              </a:defRPr>
-            </a:lvl4pPr>
-            <a:lvl5pPr>
-              <a:defRPr sz="2100" b="0">
-                <a:solidFill>
-                  <a:srgbClr val="284653"/>
-                </a:solidFill>
-                <a:latin typeface="Arial"/>
-                <a:ea typeface="Arial"/>
-                <a:cs typeface="Arial"/>
-              </a:defRPr>
-            </a:lvl5pPr>
-            <a:lvl6pPr>
-              <a:defRPr sz="2100" b="0">
-                <a:solidFill>
-                  <a:srgbClr val="284653"/>
-                </a:solidFill>
-                <a:latin typeface="Arial"/>
-                <a:ea typeface="Arial"/>
-                <a:cs typeface="Arial"/>
-              </a:defRPr>
-            </a:lvl6pPr>
-            <a:lvl7pPr>
-              <a:defRPr sz="2100" b="0">
-                <a:solidFill>
-                  <a:srgbClr val="284653"/>
-                </a:solidFill>
-                <a:latin typeface="Arial"/>
-                <a:ea typeface="Arial"/>
-                <a:cs typeface="Arial"/>
-              </a:defRPr>
-            </a:lvl7pPr>
-            <a:lvl8pPr>
-              <a:defRPr sz="2100" b="0">
-                <a:solidFill>
-                  <a:srgbClr val="284653"/>
-                </a:solidFill>
-                <a:latin typeface="Arial"/>
-                <a:ea typeface="Arial"/>
-                <a:cs typeface="Arial"/>
-              </a:defRPr>
-            </a:lvl8pPr>
-            <a:lvl9pPr>
-              <a:defRPr sz="2100" b="0">
-                <a:solidFill>
-                  <a:srgbClr val="284653"/>
-                </a:solidFill>
-                <a:latin typeface="Arial"/>
-                <a:ea typeface="Arial"/>
-                <a:cs typeface="Arial"/>
-              </a:defRPr>
-            </a:lvl9pPr>
-          </a:lstStyle>
-          <a:p xmlns:a="http://schemas.openxmlformats.org/drawingml/2006/main">
-            <a:pPr>
-              <a:defRPr sz="2100" b="0">
-                <a:solidFill>
-                  <a:srgbClr val="284653"/>
-                </a:solidFill>
-                <a:latin typeface="Arial"/>
-                <a:ea typeface="Arial"/>
-                <a:cs typeface="Arial"/>
-              </a:defRPr>
-            </a:pPr>
-            <a:r>
-              <a:rPr sz="2100" b="0">
-                <a:solidFill>
-                  <a:srgbClr val="284653"/>
-                </a:solidFill>
-                <a:latin typeface="Arial"/>
-                <a:ea typeface="Arial"/>
-                <a:cs typeface="Arial"/>
-              </a:rPr>
-              <a:t>The two readers resolve all 163,416 original Eiffel vertices, with a maximum difference of 0.016 mm between their ordinary bakes. A fresh reader reconstructs the Python bake within 0.011 mm. Native Hydra/Storm renders the derived geometry, and a real Omniverse stage reads the Python result back without a geospatial resolver.</a:t>
-            </a:r>
-          </a:p>
-        </p:txBody>
-      </p:sp>
-      <p:sp>
-        <p:nvSpPr>
-          <p:cNvPr id="4" name="">
-            <a:extLst xmlns:a="http://schemas.openxmlformats.org/drawingml/2006/main">
-              <a:ext uri="{FF2B5EF4-FFF2-40B4-BE49-F238E27FC236}">
-                <a16:creationId xmlns:a16="http://schemas.microsoft.com/office/drawing/2014/main" id="{56E9A9EB-F162-4C84-BD19-10AB71CCBA20}"/>
+                <a16:creationId xmlns:a16="http://schemas.microsoft.com/office/drawing/2014/main" id="{7ED5630B-0625-4021-9CB7-2908882FE8B0}"/>
               </a:ext>
             </a:extLst>
           </p:cNvPr>
@@ -12116,17 +11958,17 @@
                 <a:ea typeface="Arial"/>
                 <a:cs typeface="Arial"/>
               </a:rPr>
-              <a:t>Both readers use PROJ. Placement and resize are illustrative; the ground is not surveyed Paris context.</a:t>
+              <a:t>Authored placement, then USD adjustment. Tower: SDC PERFORMANCE, CC BY 4.0 (modified). Both readers use PROJ.</a:t>
             </a:r>
           </a:p>
         </p:txBody>
       </p:sp>
       <p:sp>
         <p:nvSpPr>
-          <p:cNvPr id="5" name="">
+          <p:cNvPr id="4" name="">
             <a:extLst xmlns:a="http://schemas.openxmlformats.org/drawingml/2006/main">
               <a:ext uri="{FF2B5EF4-FFF2-40B4-BE49-F238E27FC236}">
-                <a16:creationId xmlns:a16="http://schemas.microsoft.com/office/drawing/2014/main" id="{59B7574F-6A83-4166-829F-398860FE4C0B}"/>
+                <a16:creationId xmlns:a16="http://schemas.microsoft.com/office/drawing/2014/main" id="{12EF8F2F-2F0F-4229-BDB8-3D0CA0B467F6}"/>
               </a:ext>
             </a:extLst>
           </p:cNvPr>
@@ -12282,7 +12124,7 @@
     </p:spTree>
     <p:extLst>
       <p:ext uri="{BB962C8B-B14F-4D97-AF65-F5344CB8AC3E}">
-        <p14:creationId xmlns:p14="http://schemas.microsoft.com/office/powerpoint/2010/main" val="344618328"/>
+        <p14:creationId xmlns:p14="http://schemas.microsoft.com/office/powerpoint/2010/main" val="994345208"/>
       </p:ext>
     </p:extLst>
   </p:cSld>
@@ -12313,7 +12155,7 @@
           <p:cNvPr id="6" name="">
             <a:extLst xmlns:a="http://schemas.openxmlformats.org/drawingml/2006/main">
               <a:ext uri="{FF2B5EF4-FFF2-40B4-BE49-F238E27FC236}">
-                <a16:creationId xmlns:a16="http://schemas.microsoft.com/office/drawing/2014/main" id="{CAC2177B-AED7-4990-8A1A-598BB3F28D1E}"/>
+                <a16:creationId xmlns:a16="http://schemas.microsoft.com/office/drawing/2014/main" id="{22EE2845-DF1A-4021-AB46-4E195C08A812}"/>
               </a:ext>
             </a:extLst>
           </p:cNvPr>
@@ -12471,7 +12313,7 @@
           <p:cNvPr id="2" name="">
             <a:extLst xmlns:a="http://schemas.openxmlformats.org/drawingml/2006/main">
               <a:ext uri="{FF2B5EF4-FFF2-40B4-BE49-F238E27FC236}">
-                <a16:creationId xmlns:a16="http://schemas.microsoft.com/office/drawing/2014/main" id="{FA5E13B4-191F-46E1-9182-B1E8773429EA}"/>
+                <a16:creationId xmlns:a16="http://schemas.microsoft.com/office/drawing/2014/main" id="{A400D430-30DE-4D67-9CA5-82F9F2BD64DF}"/>
               </a:ext>
             </a:extLst>
           </p:cNvPr>
@@ -12629,7 +12471,7 @@
           <p:cNvPr id="3" name="">
             <a:extLst xmlns:a="http://schemas.openxmlformats.org/drawingml/2006/main">
               <a:ext uri="{FF2B5EF4-FFF2-40B4-BE49-F238E27FC236}">
-                <a16:creationId xmlns:a16="http://schemas.microsoft.com/office/drawing/2014/main" id="{8CD7F41E-FC73-44E8-9A85-4140F5224128}"/>
+                <a16:creationId xmlns:a16="http://schemas.microsoft.com/office/drawing/2014/main" id="{2804C4C9-393E-495F-813A-91C1CF6EA809}"/>
               </a:ext>
             </a:extLst>
           </p:cNvPr>
@@ -12639,7 +12481,7 @@
           <p:nvPr/>
         </p:nvPicPr>
         <p:blipFill>
-          <a:blip xmlns:r="http://schemas.openxmlformats.org/officeDocument/2006/relationships" xmlns:a="http://schemas.openxmlformats.org/drawingml/2006/main" r:embed="R5feb580c26304e1c"/>
+          <a:blip xmlns:r="http://schemas.openxmlformats.org/officeDocument/2006/relationships" xmlns:a="http://schemas.openxmlformats.org/drawingml/2006/main" r:embed="R70ead8d0aee64f31"/>
           <a:stretch xmlns:a="http://schemas.openxmlformats.org/drawingml/2006/main"/>
         </p:blipFill>
         <p:spPr>
@@ -12657,7 +12499,7 @@
           <p:cNvPr id="4" name="">
             <a:extLst xmlns:a="http://schemas.openxmlformats.org/drawingml/2006/main">
               <a:ext uri="{FF2B5EF4-FFF2-40B4-BE49-F238E27FC236}">
-                <a16:creationId xmlns:a16="http://schemas.microsoft.com/office/drawing/2014/main" id="{7B144C9E-1240-4C62-8E74-1D7F1FC2F7C8}"/>
+                <a16:creationId xmlns:a16="http://schemas.microsoft.com/office/drawing/2014/main" id="{F132BA59-FDE3-4EC7-902E-0E459CBBE0CE}"/>
               </a:ext>
             </a:extLst>
           </p:cNvPr>
@@ -12815,7 +12657,7 @@
           <p:cNvPr id="5" name="">
             <a:extLst xmlns:a="http://schemas.openxmlformats.org/drawingml/2006/main">
               <a:ext uri="{FF2B5EF4-FFF2-40B4-BE49-F238E27FC236}">
-                <a16:creationId xmlns:a16="http://schemas.microsoft.com/office/drawing/2014/main" id="{11B1AB65-2C3C-41E3-8E08-A7EC963CB38E}"/>
+                <a16:creationId xmlns:a16="http://schemas.microsoft.com/office/drawing/2014/main" id="{17C658E1-6BA0-4031-9B11-61FF40139C9C}"/>
               </a:ext>
             </a:extLst>
           </p:cNvPr>
@@ -12971,7 +12813,7 @@
     </p:spTree>
     <p:extLst>
       <p:ext uri="{BB962C8B-B14F-4D97-AF65-F5344CB8AC3E}">
-        <p14:creationId xmlns:p14="http://schemas.microsoft.com/office/powerpoint/2010/main" val="1334371111"/>
+        <p14:creationId xmlns:p14="http://schemas.microsoft.com/office/powerpoint/2010/main" val="159422859"/>
       </p:ext>
     </p:extLst>
   </p:cSld>
@@ -13002,7 +12844,7 @@
           <p:cNvPr id="6" name="">
             <a:extLst xmlns:a="http://schemas.openxmlformats.org/drawingml/2006/main">
               <a:ext uri="{FF2B5EF4-FFF2-40B4-BE49-F238E27FC236}">
-                <a16:creationId xmlns:a16="http://schemas.microsoft.com/office/drawing/2014/main" id="{ACA5A622-748B-4273-8507-DF46192ECF99}"/>
+                <a16:creationId xmlns:a16="http://schemas.microsoft.com/office/drawing/2014/main" id="{3D5B42AE-DADE-407B-BB1A-4BB6B1295682}"/>
               </a:ext>
             </a:extLst>
           </p:cNvPr>
@@ -13160,7 +13002,7 @@
           <p:cNvPr id="2" name="">
             <a:extLst xmlns:a="http://schemas.openxmlformats.org/drawingml/2006/main">
               <a:ext uri="{FF2B5EF4-FFF2-40B4-BE49-F238E27FC236}">
-                <a16:creationId xmlns:a16="http://schemas.microsoft.com/office/drawing/2014/main" id="{87E1675E-C80B-4BB9-B4FD-FABDB6325E7B}"/>
+                <a16:creationId xmlns:a16="http://schemas.microsoft.com/office/drawing/2014/main" id="{ACE0F8C7-6133-4859-838B-465535C0CB77}"/>
               </a:ext>
             </a:extLst>
           </p:cNvPr>
@@ -13170,7 +13012,7 @@
           <p:nvPr/>
         </p:nvPicPr>
         <p:blipFill>
-          <a:blip xmlns:r="http://schemas.openxmlformats.org/officeDocument/2006/relationships" xmlns:a="http://schemas.openxmlformats.org/drawingml/2006/main" r:embed="R253ac7bd0fa84b4e"/>
+          <a:blip xmlns:r="http://schemas.openxmlformats.org/officeDocument/2006/relationships" xmlns:a="http://schemas.openxmlformats.org/drawingml/2006/main" r:embed="R5a5c47299f5d4fe5"/>
           <a:stretch xmlns:a="http://schemas.openxmlformats.org/drawingml/2006/main"/>
         </p:blipFill>
         <p:spPr>
@@ -13188,7 +13030,7 @@
           <p:cNvPr id="3" name="">
             <a:extLst xmlns:a="http://schemas.openxmlformats.org/drawingml/2006/main">
               <a:ext uri="{FF2B5EF4-FFF2-40B4-BE49-F238E27FC236}">
-                <a16:creationId xmlns:a16="http://schemas.microsoft.com/office/drawing/2014/main" id="{E2B54C26-C4B6-4B5B-80EF-A803AE466E87}"/>
+                <a16:creationId xmlns:a16="http://schemas.microsoft.com/office/drawing/2014/main" id="{2971DAD4-DD59-4145-8030-C8678DC3D46B}"/>
               </a:ext>
             </a:extLst>
           </p:cNvPr>
@@ -13346,7 +13188,7 @@
           <p:cNvPr id="4" name="">
             <a:extLst xmlns:a="http://schemas.openxmlformats.org/drawingml/2006/main">
               <a:ext uri="{FF2B5EF4-FFF2-40B4-BE49-F238E27FC236}">
-                <a16:creationId xmlns:a16="http://schemas.microsoft.com/office/drawing/2014/main" id="{E56653F4-6057-4DB9-9385-133D09E4AF03}"/>
+                <a16:creationId xmlns:a16="http://schemas.microsoft.com/office/drawing/2014/main" id="{EA6A8F96-15B2-460F-8409-D26389211AFE}"/>
               </a:ext>
             </a:extLst>
           </p:cNvPr>
@@ -13504,7 +13346,7 @@
           <p:cNvPr id="5" name="">
             <a:extLst xmlns:a="http://schemas.openxmlformats.org/drawingml/2006/main">
               <a:ext uri="{FF2B5EF4-FFF2-40B4-BE49-F238E27FC236}">
-                <a16:creationId xmlns:a16="http://schemas.microsoft.com/office/drawing/2014/main" id="{C963A69B-E175-4B2B-AC3A-76B7C151C06B}"/>
+                <a16:creationId xmlns:a16="http://schemas.microsoft.com/office/drawing/2014/main" id="{70C51C63-C627-46E8-BDD5-DF64D8FD10AD}"/>
               </a:ext>
             </a:extLst>
           </p:cNvPr>
@@ -13660,7 +13502,7 @@
     </p:spTree>
     <p:extLst>
       <p:ext uri="{BB962C8B-B14F-4D97-AF65-F5344CB8AC3E}">
-        <p14:creationId xmlns:p14="http://schemas.microsoft.com/office/powerpoint/2010/main" val="1247283234"/>
+        <p14:creationId xmlns:p14="http://schemas.microsoft.com/office/powerpoint/2010/main" val="1531973330"/>
       </p:ext>
     </p:extLst>
   </p:cSld>
@@ -13691,7 +13533,7 @@
           <p:cNvPr id="6" name="">
             <a:extLst xmlns:a="http://schemas.openxmlformats.org/drawingml/2006/main">
               <a:ext uri="{FF2B5EF4-FFF2-40B4-BE49-F238E27FC236}">
-                <a16:creationId xmlns:a16="http://schemas.microsoft.com/office/drawing/2014/main" id="{72B5717A-0734-47F2-8275-A1E76CAF6162}"/>
+                <a16:creationId xmlns:a16="http://schemas.microsoft.com/office/drawing/2014/main" id="{7D027B9D-CCE1-4FEA-A224-27196876C6E3}"/>
               </a:ext>
             </a:extLst>
           </p:cNvPr>
@@ -13849,7 +13691,7 @@
           <p:cNvPr id="2" name="">
             <a:extLst xmlns:a="http://schemas.openxmlformats.org/drawingml/2006/main">
               <a:ext uri="{FF2B5EF4-FFF2-40B4-BE49-F238E27FC236}">
-                <a16:creationId xmlns:a16="http://schemas.microsoft.com/office/drawing/2014/main" id="{3AAEE604-685B-4129-BFEE-F73389E99576}"/>
+                <a16:creationId xmlns:a16="http://schemas.microsoft.com/office/drawing/2014/main" id="{6FFCB925-06D3-4C91-A679-8CE02D74892E}"/>
               </a:ext>
             </a:extLst>
           </p:cNvPr>
@@ -14007,7 +13849,7 @@
           <p:cNvPr id="3" name="">
             <a:extLst xmlns:a="http://schemas.openxmlformats.org/drawingml/2006/main">
               <a:ext uri="{FF2B5EF4-FFF2-40B4-BE49-F238E27FC236}">
-                <a16:creationId xmlns:a16="http://schemas.microsoft.com/office/drawing/2014/main" id="{A89B3035-EB2F-42A2-A823-9E64A9E8717D}"/>
+                <a16:creationId xmlns:a16="http://schemas.microsoft.com/office/drawing/2014/main" id="{60178EB3-867B-44D4-82A7-35560E097784}"/>
               </a:ext>
             </a:extLst>
           </p:cNvPr>
@@ -14017,7 +13859,7 @@
           <p:nvPr/>
         </p:nvPicPr>
         <p:blipFill>
-          <a:blip xmlns:r="http://schemas.openxmlformats.org/officeDocument/2006/relationships" xmlns:a="http://schemas.openxmlformats.org/drawingml/2006/main" r:embed="R958571bd61554c05"/>
+          <a:blip xmlns:r="http://schemas.openxmlformats.org/officeDocument/2006/relationships" xmlns:a="http://schemas.openxmlformats.org/drawingml/2006/main" r:embed="R0c93dbf42417410a"/>
           <a:stretch xmlns:a="http://schemas.openxmlformats.org/drawingml/2006/main"/>
         </p:blipFill>
         <p:spPr>
@@ -14035,7 +13877,7 @@
           <p:cNvPr id="4" name="">
             <a:extLst xmlns:a="http://schemas.openxmlformats.org/drawingml/2006/main">
               <a:ext uri="{FF2B5EF4-FFF2-40B4-BE49-F238E27FC236}">
-                <a16:creationId xmlns:a16="http://schemas.microsoft.com/office/drawing/2014/main" id="{C6CC9662-BC28-4F15-A3DD-95D7D4766C59}"/>
+                <a16:creationId xmlns:a16="http://schemas.microsoft.com/office/drawing/2014/main" id="{11CCCAFB-18E1-4661-923A-C971DD42CF1E}"/>
               </a:ext>
             </a:extLst>
           </p:cNvPr>
@@ -14193,7 +14035,7 @@
           <p:cNvPr id="5" name="">
             <a:extLst xmlns:a="http://schemas.openxmlformats.org/drawingml/2006/main">
               <a:ext uri="{FF2B5EF4-FFF2-40B4-BE49-F238E27FC236}">
-                <a16:creationId xmlns:a16="http://schemas.microsoft.com/office/drawing/2014/main" id="{27F0A379-3B6B-4575-B8ED-BE151641C640}"/>
+                <a16:creationId xmlns:a16="http://schemas.microsoft.com/office/drawing/2014/main" id="{25086ACC-1E18-4973-853D-5AA6560A5CAC}"/>
               </a:ext>
             </a:extLst>
           </p:cNvPr>
@@ -14349,7 +14191,7 @@
     </p:spTree>
     <p:extLst>
       <p:ext uri="{BB962C8B-B14F-4D97-AF65-F5344CB8AC3E}">
-        <p14:creationId xmlns:p14="http://schemas.microsoft.com/office/powerpoint/2010/main" val="613729602"/>
+        <p14:creationId xmlns:p14="http://schemas.microsoft.com/office/powerpoint/2010/main" val="1470289418"/>
       </p:ext>
     </p:extLst>
   </p:cSld>
@@ -14380,7 +14222,7 @@
           <p:cNvPr id="6" name="">
             <a:extLst xmlns:a="http://schemas.openxmlformats.org/drawingml/2006/main">
               <a:ext uri="{FF2B5EF4-FFF2-40B4-BE49-F238E27FC236}">
-                <a16:creationId xmlns:a16="http://schemas.microsoft.com/office/drawing/2014/main" id="{F57B352E-57A8-4509-B33B-E406D9DF5850}"/>
+                <a16:creationId xmlns:a16="http://schemas.microsoft.com/office/drawing/2014/main" id="{2A101A8F-D6E6-463C-9655-686AD0E313FC}"/>
               </a:ext>
             </a:extLst>
           </p:cNvPr>
@@ -14538,7 +14380,7 @@
           <p:cNvPr id="2" name="">
             <a:extLst xmlns:a="http://schemas.openxmlformats.org/drawingml/2006/main">
               <a:ext uri="{FF2B5EF4-FFF2-40B4-BE49-F238E27FC236}">
-                <a16:creationId xmlns:a16="http://schemas.microsoft.com/office/drawing/2014/main" id="{15D040F5-8D5A-48CB-B7C3-E4F33AD897FF}"/>
+                <a16:creationId xmlns:a16="http://schemas.microsoft.com/office/drawing/2014/main" id="{C577EB99-4C66-407D-95DB-3911F04DA934}"/>
               </a:ext>
             </a:extLst>
           </p:cNvPr>
@@ -14696,7 +14538,7 @@
           <p:cNvPr id="3" name="">
             <a:extLst xmlns:a="http://schemas.openxmlformats.org/drawingml/2006/main">
               <a:ext uri="{FF2B5EF4-FFF2-40B4-BE49-F238E27FC236}">
-                <a16:creationId xmlns:a16="http://schemas.microsoft.com/office/drawing/2014/main" id="{DCBE39F0-7B89-4D86-BBAA-33FB11FC4D1E}"/>
+                <a16:creationId xmlns:a16="http://schemas.microsoft.com/office/drawing/2014/main" id="{172C34FF-1510-4ADD-823C-58D14E0D7836}"/>
               </a:ext>
             </a:extLst>
           </p:cNvPr>
@@ -15156,7 +14998,7 @@
           <p:cNvPr id="4" name="">
             <a:extLst xmlns:a="http://schemas.openxmlformats.org/drawingml/2006/main">
               <a:ext uri="{FF2B5EF4-FFF2-40B4-BE49-F238E27FC236}">
-                <a16:creationId xmlns:a16="http://schemas.microsoft.com/office/drawing/2014/main" id="{B43ED880-2B84-4457-B5F1-1EA06392E9FF}"/>
+                <a16:creationId xmlns:a16="http://schemas.microsoft.com/office/drawing/2014/main" id="{6B18B300-BF6B-4C6E-9842-895D861EEB9C}"/>
               </a:ext>
             </a:extLst>
           </p:cNvPr>
@@ -15314,7 +15156,7 @@
           <p:cNvPr id="5" name="">
             <a:extLst xmlns:a="http://schemas.openxmlformats.org/drawingml/2006/main">
               <a:ext uri="{FF2B5EF4-FFF2-40B4-BE49-F238E27FC236}">
-                <a16:creationId xmlns:a16="http://schemas.microsoft.com/office/drawing/2014/main" id="{5B5D6109-1038-48EC-9D60-88577A2001C3}"/>
+                <a16:creationId xmlns:a16="http://schemas.microsoft.com/office/drawing/2014/main" id="{0098DA19-7269-4BC7-97B7-54746099153F}"/>
               </a:ext>
             </a:extLst>
           </p:cNvPr>
@@ -15470,7 +15312,7 @@
     </p:spTree>
     <p:extLst>
       <p:ext uri="{BB962C8B-B14F-4D97-AF65-F5344CB8AC3E}">
-        <p14:creationId xmlns:p14="http://schemas.microsoft.com/office/powerpoint/2010/main" val="1746312716"/>
+        <p14:creationId xmlns:p14="http://schemas.microsoft.com/office/powerpoint/2010/main" val="1777561545"/>
       </p:ext>
     </p:extLst>
   </p:cSld>

</xml_diff>